<commit_message>
Remove contributions slide content and prep files from repo
</commit_message>
<xml_diff>
--- a/docs/MetaCost_Presentation.pptx
+++ b/docs/MetaCost_Presentation.pptx
@@ -796,7 +796,7 @@
           <a:lstStyle/>
           <a:p>
             <a:r>
-              <a:t>Run: streamlit run app/streamlit_app.py. Demo order: (1) Data tab: show the 5-day trend. (2) Predict an unseen day: choose Subject 2, Day 5 (MSE 0.093), then drag the calibration slider to 3: MSE falls to 0.016 and the yellow diamonds show the 3 mask readings. (3) What-if: drag the EMG_R4 slider and watch the predicted cost change. (4) Results tab: leaderboard. Backup: python scripts/predict.py --demo --subject S1</a:t>
+              <a:t>Open a terminal in the project folder (cd into ML proj). Run the three commands in order. (1) The paper reproduction prints linear-regression MSE 0.0107 and R2 0.83 for Subject 1. (2) predict.py trains a Gaussian Process on 4 days and predicts each unseen day; errors of about 11-17 %. (3) pytest shows all 10 tests pass. Total under a minute.</a:t>
             </a:r>
           </a:p>
         </p:txBody>
@@ -936,7 +936,7 @@
           <a:lstStyle/>
           <a:p>
             <a:r>
-              <a:t>Mukil: extended study, calibration, dashboard. Likhith: faithful MATLAB-to-Python port and GitHub repo.</a:t>
+              <a:t>Thank the panel and invite questions.</a:t>
             </a:r>
           </a:p>
         </p:txBody>
@@ -6252,7 +6252,7 @@
                 </a:solidFill>
                 <a:latin typeface="Cambria"/>
               </a:rPr>
-              <a:t>Live demo: interactive dashboard</a:t>
+              <a:t>Live demo: the code, running</a:t>
             </a:r>
           </a:p>
         </p:txBody>
@@ -6327,44 +6327,15 @@
           </a:p>
         </p:txBody>
       </p:sp>
-      <p:pic>
-        <p:nvPicPr>
-          <p:cNvPr id="6" name="Picture 5" descr="app_screenshot.jpg"/>
-          <p:cNvPicPr>
-            <a:picLocks noChangeAspect="1"/>
-          </p:cNvPicPr>
-          <p:nvPr/>
-        </p:nvPicPr>
-        <p:blipFill>
-          <a:blip r:embed="rId3"/>
-          <a:stretch>
-            <a:fillRect/>
-          </a:stretch>
-        </p:blipFill>
-        <p:spPr>
-          <a:xfrm>
-            <a:off x="548640" y="1436751"/>
-            <a:ext cx="6949440" cy="4213098"/>
-          </a:xfrm>
-          <a:prstGeom prst="rect">
-            <a:avLst/>
-          </a:prstGeom>
-          <a:ln w="12700">
-            <a:solidFill>
-              <a:srgbClr val="D0D5DD"/>
-            </a:solidFill>
-          </a:ln>
-        </p:spPr>
-      </p:pic>
-      <p:sp>
-        <p:nvSpPr>
-          <p:cNvPr id="7" name="Oval 6"/>
+      <p:sp>
+        <p:nvSpPr>
+          <p:cNvPr id="6" name="Oval 5"/>
           <p:cNvSpPr/>
           <p:nvPr/>
         </p:nvSpPr>
         <p:spPr>
           <a:xfrm>
-            <a:off x="7818120" y="1508760"/>
+            <a:off x="548640" y="1508760"/>
             <a:ext cx="457200" cy="457200"/>
           </a:xfrm>
           <a:prstGeom prst="ellipse">
@@ -6410,14 +6381,14 @@
       </p:sp>
       <p:sp>
         <p:nvSpPr>
-          <p:cNvPr id="8" name="TextBox 7"/>
-          <p:cNvSpPr txBox="1"/>
-          <p:nvPr/>
-        </p:nvSpPr>
-        <p:spPr>
-          <a:xfrm>
-            <a:off x="8412480" y="1463040"/>
-            <a:ext cx="3291840" cy="777240"/>
+          <p:cNvPr id="7" name="TextBox 6"/>
+          <p:cNvSpPr txBox="1"/>
+          <p:nvPr/>
+        </p:nvSpPr>
+        <p:spPr>
+          <a:xfrm>
+            <a:off x="1143000" y="1554480"/>
+            <a:ext cx="2926080" cy="411480"/>
           </a:xfrm>
           <a:prstGeom prst="rect">
             <a:avLst/>
@@ -6432,439 +6403,31 @@
           <a:p>
             <a:pPr algn="l"/>
             <a:r>
-              <a:rPr sz="1600" b="1" i="0">
+              <a:rPr sz="1700" b="1" i="0">
                 <a:solidFill>
                   <a:srgbClr val="0F1B2D"/>
                 </a:solidFill>
                 <a:latin typeface="Calibri"/>
               </a:rPr>
-              <a:t>Data</a:t>
-            </a:r>
-          </a:p>
-          <a:p>
-            <a:pPr algn="l"/>
-            <a:r>
-              <a:rPr sz="1300" b="0" i="0">
-                <a:solidFill>
-                  <a:srgbClr val="555B66"/>
-                </a:solidFill>
-                <a:latin typeface="Calibri"/>
-              </a:rPr>
-              <a:t>5-day trajectories, correlations, raw table</a:t>
-            </a:r>
-          </a:p>
-        </p:txBody>
-      </p:sp>
-      <p:sp>
-        <p:nvSpPr>
-          <p:cNvPr id="9" name="Oval 8"/>
+              <a:t>Paper reproduction</a:t>
+            </a:r>
+          </a:p>
+        </p:txBody>
+      </p:sp>
+      <p:sp>
+        <p:nvSpPr>
+          <p:cNvPr id="8" name="Rounded Rectangle 7"/>
           <p:cNvSpPr/>
           <p:nvPr/>
         </p:nvSpPr>
         <p:spPr>
           <a:xfrm>
-            <a:off x="7818120" y="2359152"/>
-            <a:ext cx="457200" cy="457200"/>
-          </a:xfrm>
-          <a:prstGeom prst="ellipse">
-            <a:avLst/>
-          </a:prstGeom>
-          <a:solidFill>
-            <a:srgbClr val="2A78D6"/>
-          </a:solidFill>
-          <a:ln>
-            <a:noFill/>
-          </a:ln>
-        </p:spPr>
-        <p:style>
-          <a:lnRef idx="1">
-            <a:schemeClr val="accent1"/>
-          </a:lnRef>
-          <a:fillRef idx="3">
-            <a:schemeClr val="accent1"/>
-          </a:fillRef>
-          <a:effectRef idx="2">
-            <a:schemeClr val="accent1"/>
-          </a:effectRef>
-          <a:fontRef idx="minor">
-            <a:schemeClr val="lt1"/>
-          </a:fontRef>
-        </p:style>
-        <p:txBody>
-          <a:bodyPr rtlCol="0" anchor="ctr" lIns="0" rIns="0" tIns="0" bIns="0"/>
-          <a:lstStyle/>
-          <a:p>
-            <a:pPr algn="ctr"/>
-            <a:r>
-              <a:rPr sz="1600" b="1">
-                <a:solidFill>
-                  <a:srgbClr val="FFFFFF"/>
-                </a:solidFill>
-                <a:latin typeface="Calibri"/>
-              </a:rPr>
-              <a:t>2</a:t>
-            </a:r>
-          </a:p>
-        </p:txBody>
-      </p:sp>
-      <p:sp>
-        <p:nvSpPr>
-          <p:cNvPr id="10" name="TextBox 9"/>
-          <p:cNvSpPr txBox="1"/>
-          <p:nvPr/>
-        </p:nvSpPr>
-        <p:spPr>
-          <a:xfrm>
-            <a:off x="8412480" y="2313432"/>
-            <a:ext cx="3291840" cy="777240"/>
-          </a:xfrm>
-          <a:prstGeom prst="rect">
-            <a:avLst/>
-          </a:prstGeom>
-          <a:noFill/>
-        </p:spPr>
-        <p:txBody>
-          <a:bodyPr wrap="square" anchor="t" lIns="0" rIns="0" tIns="0" bIns="0">
-            <a:spAutoFit/>
-          </a:bodyPr>
-          <a:lstStyle/>
-          <a:p>
-            <a:pPr algn="l"/>
-            <a:r>
-              <a:rPr sz="1600" b="1" i="0">
-                <a:solidFill>
-                  <a:srgbClr val="0F1B2D"/>
-                </a:solidFill>
-                <a:latin typeface="Calibri"/>
-              </a:rPr>
-              <a:t>Predict an unseen day</a:t>
-            </a:r>
-          </a:p>
-          <a:p>
-            <a:pPr algn="l"/>
-            <a:r>
-              <a:rPr sz="1300" b="0" i="0">
-                <a:solidFill>
-                  <a:srgbClr val="555B66"/>
-                </a:solidFill>
-                <a:latin typeface="Calibri"/>
-              </a:rPr>
-              <a:t>live retraining on 4 days + calibration slider (S2 day 5: 0.093 → 0.016)</a:t>
-            </a:r>
-          </a:p>
-        </p:txBody>
-      </p:sp>
-      <p:sp>
-        <p:nvSpPr>
-          <p:cNvPr id="11" name="Oval 10"/>
-          <p:cNvSpPr/>
-          <p:nvPr/>
-        </p:nvSpPr>
-        <p:spPr>
-          <a:xfrm>
-            <a:off x="7818120" y="3209544"/>
-            <a:ext cx="457200" cy="457200"/>
-          </a:xfrm>
-          <a:prstGeom prst="ellipse">
-            <a:avLst/>
-          </a:prstGeom>
-          <a:solidFill>
-            <a:srgbClr val="2A78D6"/>
-          </a:solidFill>
-          <a:ln>
-            <a:noFill/>
-          </a:ln>
-        </p:spPr>
-        <p:style>
-          <a:lnRef idx="1">
-            <a:schemeClr val="accent1"/>
-          </a:lnRef>
-          <a:fillRef idx="3">
-            <a:schemeClr val="accent1"/>
-          </a:fillRef>
-          <a:effectRef idx="2">
-            <a:schemeClr val="accent1"/>
-          </a:effectRef>
-          <a:fontRef idx="minor">
-            <a:schemeClr val="lt1"/>
-          </a:fontRef>
-        </p:style>
-        <p:txBody>
-          <a:bodyPr rtlCol="0" anchor="ctr" lIns="0" rIns="0" tIns="0" bIns="0"/>
-          <a:lstStyle/>
-          <a:p>
-            <a:pPr algn="ctr"/>
-            <a:r>
-              <a:rPr sz="1600" b="1">
-                <a:solidFill>
-                  <a:srgbClr val="FFFFFF"/>
-                </a:solidFill>
-                <a:latin typeface="Calibri"/>
-              </a:rPr>
-              <a:t>3</a:t>
-            </a:r>
-          </a:p>
-        </p:txBody>
-      </p:sp>
-      <p:sp>
-        <p:nvSpPr>
-          <p:cNvPr id="12" name="TextBox 11"/>
-          <p:cNvSpPr txBox="1"/>
-          <p:nvPr/>
-        </p:nvSpPr>
-        <p:spPr>
-          <a:xfrm>
-            <a:off x="8412480" y="3163824"/>
-            <a:ext cx="3291840" cy="777240"/>
-          </a:xfrm>
-          <a:prstGeom prst="rect">
-            <a:avLst/>
-          </a:prstGeom>
-          <a:noFill/>
-        </p:spPr>
-        <p:txBody>
-          <a:bodyPr wrap="square" anchor="t" lIns="0" rIns="0" tIns="0" bIns="0">
-            <a:spAutoFit/>
-          </a:bodyPr>
-          <a:lstStyle/>
-          <a:p>
-            <a:pPr algn="l"/>
-            <a:r>
-              <a:rPr sz="1600" b="1" i="0">
-                <a:solidFill>
-                  <a:srgbClr val="0F1B2D"/>
-                </a:solidFill>
-                <a:latin typeface="Calibri"/>
-              </a:rPr>
-              <a:t>What-if simulator</a:t>
-            </a:r>
-          </a:p>
-          <a:p>
-            <a:pPr algn="l"/>
-            <a:r>
-              <a:rPr sz="1300" b="0" i="0">
-                <a:solidFill>
-                  <a:srgbClr val="555B66"/>
-                </a:solidFill>
-                <a:latin typeface="Calibri"/>
-              </a:rPr>
-              <a:t>drag sensor sliders → cost ± uncertainty</a:t>
-            </a:r>
-          </a:p>
-        </p:txBody>
-      </p:sp>
-      <p:sp>
-        <p:nvSpPr>
-          <p:cNvPr id="13" name="Oval 12"/>
-          <p:cNvSpPr/>
-          <p:nvPr/>
-        </p:nvSpPr>
-        <p:spPr>
-          <a:xfrm>
-            <a:off x="7818120" y="4059936"/>
-            <a:ext cx="457200" cy="457200"/>
-          </a:xfrm>
-          <a:prstGeom prst="ellipse">
-            <a:avLst/>
-          </a:prstGeom>
-          <a:solidFill>
-            <a:srgbClr val="2A78D6"/>
-          </a:solidFill>
-          <a:ln>
-            <a:noFill/>
-          </a:ln>
-        </p:spPr>
-        <p:style>
-          <a:lnRef idx="1">
-            <a:schemeClr val="accent1"/>
-          </a:lnRef>
-          <a:fillRef idx="3">
-            <a:schemeClr val="accent1"/>
-          </a:fillRef>
-          <a:effectRef idx="2">
-            <a:schemeClr val="accent1"/>
-          </a:effectRef>
-          <a:fontRef idx="minor">
-            <a:schemeClr val="lt1"/>
-          </a:fontRef>
-        </p:style>
-        <p:txBody>
-          <a:bodyPr rtlCol="0" anchor="ctr" lIns="0" rIns="0" tIns="0" bIns="0"/>
-          <a:lstStyle/>
-          <a:p>
-            <a:pPr algn="ctr"/>
-            <a:r>
-              <a:rPr sz="1600" b="1">
-                <a:solidFill>
-                  <a:srgbClr val="FFFFFF"/>
-                </a:solidFill>
-                <a:latin typeface="Calibri"/>
-              </a:rPr>
-              <a:t>4</a:t>
-            </a:r>
-          </a:p>
-        </p:txBody>
-      </p:sp>
-      <p:sp>
-        <p:nvSpPr>
-          <p:cNvPr id="14" name="TextBox 13"/>
-          <p:cNvSpPr txBox="1"/>
-          <p:nvPr/>
-        </p:nvSpPr>
-        <p:spPr>
-          <a:xfrm>
-            <a:off x="8412480" y="4014216"/>
-            <a:ext cx="3291840" cy="777240"/>
-          </a:xfrm>
-          <a:prstGeom prst="rect">
-            <a:avLst/>
-          </a:prstGeom>
-          <a:noFill/>
-        </p:spPr>
-        <p:txBody>
-          <a:bodyPr wrap="square" anchor="t" lIns="0" rIns="0" tIns="0" bIns="0">
-            <a:spAutoFit/>
-          </a:bodyPr>
-          <a:lstStyle/>
-          <a:p>
-            <a:pPr algn="l"/>
-            <a:r>
-              <a:rPr sz="1600" b="1" i="0">
-                <a:solidFill>
-                  <a:srgbClr val="0F1B2D"/>
-                </a:solidFill>
-                <a:latin typeface="Calibri"/>
-              </a:rPr>
-              <a:t>Results</a:t>
-            </a:r>
-          </a:p>
-          <a:p>
-            <a:pPr algn="l"/>
-            <a:r>
-              <a:rPr sz="1300" b="0" i="0">
-                <a:solidFill>
-                  <a:srgbClr val="555B66"/>
-                </a:solidFill>
-                <a:latin typeface="Calibri"/>
-              </a:rPr>
-              <a:t>leaderboard for both protocols + all figures</a:t>
-            </a:r>
-          </a:p>
-        </p:txBody>
-      </p:sp>
-      <p:sp>
-        <p:nvSpPr>
-          <p:cNvPr id="15" name="Oval 14"/>
-          <p:cNvSpPr/>
-          <p:nvPr/>
-        </p:nvSpPr>
-        <p:spPr>
-          <a:xfrm>
-            <a:off x="7818120" y="4910328"/>
-            <a:ext cx="457200" cy="457200"/>
-          </a:xfrm>
-          <a:prstGeom prst="ellipse">
-            <a:avLst/>
-          </a:prstGeom>
-          <a:solidFill>
-            <a:srgbClr val="2A78D6"/>
-          </a:solidFill>
-          <a:ln>
-            <a:noFill/>
-          </a:ln>
-        </p:spPr>
-        <p:style>
-          <a:lnRef idx="1">
-            <a:schemeClr val="accent1"/>
-          </a:lnRef>
-          <a:fillRef idx="3">
-            <a:schemeClr val="accent1"/>
-          </a:fillRef>
-          <a:effectRef idx="2">
-            <a:schemeClr val="accent1"/>
-          </a:effectRef>
-          <a:fontRef idx="minor">
-            <a:schemeClr val="lt1"/>
-          </a:fontRef>
-        </p:style>
-        <p:txBody>
-          <a:bodyPr rtlCol="0" anchor="ctr" lIns="0" rIns="0" tIns="0" bIns="0"/>
-          <a:lstStyle/>
-          <a:p>
-            <a:pPr algn="ctr"/>
-            <a:r>
-              <a:rPr sz="1600" b="1">
-                <a:solidFill>
-                  <a:srgbClr val="FFFFFF"/>
-                </a:solidFill>
-                <a:latin typeface="Calibri"/>
-              </a:rPr>
-              <a:t>5</a:t>
-            </a:r>
-          </a:p>
-        </p:txBody>
-      </p:sp>
-      <p:sp>
-        <p:nvSpPr>
-          <p:cNvPr id="16" name="TextBox 15"/>
-          <p:cNvSpPr txBox="1"/>
-          <p:nvPr/>
-        </p:nvSpPr>
-        <p:spPr>
-          <a:xfrm>
-            <a:off x="8412480" y="4864608"/>
-            <a:ext cx="3291840" cy="777240"/>
-          </a:xfrm>
-          <a:prstGeom prst="rect">
-            <a:avLst/>
-          </a:prstGeom>
-          <a:noFill/>
-        </p:spPr>
-        <p:txBody>
-          <a:bodyPr wrap="square" anchor="t" lIns="0" rIns="0" tIns="0" bIns="0">
-            <a:spAutoFit/>
-          </a:bodyPr>
-          <a:lstStyle/>
-          <a:p>
-            <a:pPr algn="l"/>
-            <a:r>
-              <a:rPr sz="1600" b="1" i="0">
-                <a:solidFill>
-                  <a:srgbClr val="0F1B2D"/>
-                </a:solidFill>
-                <a:latin typeface="Calibri"/>
-              </a:rPr>
-              <a:t>Batch predict</a:t>
-            </a:r>
-          </a:p>
-          <a:p>
-            <a:pPr algn="l"/>
-            <a:r>
-              <a:rPr sz="1300" b="0" i="0">
-                <a:solidFill>
-                  <a:srgbClr val="555B66"/>
-                </a:solidFill>
-                <a:latin typeface="Calibri"/>
-              </a:rPr>
-              <a:t>upload CSV → download predictions</a:t>
-            </a:r>
-          </a:p>
-        </p:txBody>
-      </p:sp>
-      <p:sp>
-        <p:nvSpPr>
-          <p:cNvPr id="17" name="Rounded Rectangle 16"/>
-          <p:cNvSpPr/>
-          <p:nvPr/>
-        </p:nvSpPr>
-        <p:spPr>
-          <a:xfrm>
-            <a:off x="548640" y="5806440"/>
-            <a:ext cx="6949440" cy="457200"/>
+            <a:off x="548640" y="2148840"/>
+            <a:ext cx="3520440" cy="3566160"/>
           </a:xfrm>
           <a:prstGeom prst="roundRect">
             <a:avLst>
-              <a:gd name="adj" fmla="val 15000"/>
+              <a:gd name="adj" fmla="val 5000"/>
             </a:avLst>
           </a:prstGeom>
           <a:solidFill>
@@ -6899,35 +6462,607 @@
       </p:sp>
       <p:sp>
         <p:nvSpPr>
-          <p:cNvPr id="18" name="TextBox 17"/>
-          <p:cNvSpPr txBox="1"/>
-          <p:nvPr/>
-        </p:nvSpPr>
-        <p:spPr>
-          <a:xfrm>
-            <a:off x="777240" y="5806440"/>
-            <a:ext cx="6583680" cy="457200"/>
-          </a:xfrm>
-          <a:prstGeom prst="rect">
-            <a:avLst/>
-          </a:prstGeom>
-          <a:noFill/>
-        </p:spPr>
-        <p:txBody>
-          <a:bodyPr wrap="square" anchor="ctr" lIns="0" rIns="0" tIns="0" bIns="0">
-            <a:spAutoFit/>
-          </a:bodyPr>
-          <a:lstStyle/>
-          <a:p>
-            <a:pPr algn="l"/>
-            <a:r>
-              <a:rPr sz="1500" b="0" i="0">
+          <p:cNvPr id="9" name="TextBox 8"/>
+          <p:cNvSpPr txBox="1"/>
+          <p:nvPr/>
+        </p:nvSpPr>
+        <p:spPr>
+          <a:xfrm>
+            <a:off x="731520" y="2286000"/>
+            <a:ext cx="3200400" cy="822960"/>
+          </a:xfrm>
+          <a:prstGeom prst="rect">
+            <a:avLst/>
+          </a:prstGeom>
+          <a:noFill/>
+        </p:spPr>
+        <p:txBody>
+          <a:bodyPr wrap="square" anchor="t" lIns="0" rIns="0" tIns="0" bIns="0">
+            <a:spAutoFit/>
+          </a:bodyPr>
+          <a:lstStyle/>
+          <a:p>
+            <a:pPr algn="l"/>
+            <a:r>
+              <a:rPr sz="1200" b="0" i="0">
+                <a:solidFill>
+                  <a:srgbClr val="BFD4F2"/>
+                </a:solidFill>
+                <a:latin typeface="Courier New"/>
+              </a:rPr>
+              <a:t>$ python paper_reproduction/lin_reg_test.py</a:t>
+            </a:r>
+          </a:p>
+        </p:txBody>
+      </p:sp>
+      <p:sp>
+        <p:nvSpPr>
+          <p:cNvPr id="10" name="TextBox 9"/>
+          <p:cNvSpPr txBox="1"/>
+          <p:nvPr/>
+        </p:nvSpPr>
+        <p:spPr>
+          <a:xfrm>
+            <a:off x="731520" y="3154680"/>
+            <a:ext cx="3200400" cy="2468880"/>
+          </a:xfrm>
+          <a:prstGeom prst="rect">
+            <a:avLst/>
+          </a:prstGeom>
+          <a:noFill/>
+        </p:spPr>
+        <p:txBody>
+          <a:bodyPr wrap="square" anchor="t" lIns="0" rIns="0" tIns="0" bIns="0">
+            <a:spAutoFit/>
+          </a:bodyPr>
+          <a:lstStyle/>
+          <a:p>
+            <a:pPr algn="l"/>
+            <a:r>
+              <a:rPr sz="1200" b="0" i="0">
                 <a:solidFill>
                   <a:srgbClr val="FFFFFF"/>
                 </a:solidFill>
                 <a:latin typeface="Courier New"/>
               </a:rPr>
-              <a:t>$  streamlit run app/streamlit_app.py</a:t>
+              <a:t>Linear Regression 5-Fold CV</a:t>
+            </a:r>
+          </a:p>
+          <a:p>
+            <a:pPr algn="l"/>
+            <a:r>
+              <a:rPr sz="1200" b="0" i="0">
+                <a:solidFill>
+                  <a:srgbClr val="FFFFFF"/>
+                </a:solidFill>
+                <a:latin typeface="Courier New"/>
+              </a:rPr>
+              <a:t>Mean MSE: 0.010700</a:t>
+            </a:r>
+          </a:p>
+          <a:p>
+            <a:pPr algn="l"/>
+            <a:r>
+              <a:rPr sz="1200" b="0" i="0">
+                <a:solidFill>
+                  <a:srgbClr val="FFFFFF"/>
+                </a:solidFill>
+                <a:latin typeface="Courier New"/>
+              </a:rPr>
+              <a:t>Mean R² : 0.8349</a:t>
+            </a:r>
+          </a:p>
+        </p:txBody>
+      </p:sp>
+      <p:sp>
+        <p:nvSpPr>
+          <p:cNvPr id="11" name="Oval 10"/>
+          <p:cNvSpPr/>
+          <p:nvPr/>
+        </p:nvSpPr>
+        <p:spPr>
+          <a:xfrm>
+            <a:off x="4297679" y="1508760"/>
+            <a:ext cx="457200" cy="457200"/>
+          </a:xfrm>
+          <a:prstGeom prst="ellipse">
+            <a:avLst/>
+          </a:prstGeom>
+          <a:solidFill>
+            <a:srgbClr val="2A78D6"/>
+          </a:solidFill>
+          <a:ln>
+            <a:noFill/>
+          </a:ln>
+        </p:spPr>
+        <p:style>
+          <a:lnRef idx="1">
+            <a:schemeClr val="accent1"/>
+          </a:lnRef>
+          <a:fillRef idx="3">
+            <a:schemeClr val="accent1"/>
+          </a:fillRef>
+          <a:effectRef idx="2">
+            <a:schemeClr val="accent1"/>
+          </a:effectRef>
+          <a:fontRef idx="minor">
+            <a:schemeClr val="lt1"/>
+          </a:fontRef>
+        </p:style>
+        <p:txBody>
+          <a:bodyPr rtlCol="0" anchor="ctr" lIns="0" rIns="0" tIns="0" bIns="0"/>
+          <a:lstStyle/>
+          <a:p>
+            <a:pPr algn="ctr"/>
+            <a:r>
+              <a:rPr sz="1600" b="1">
+                <a:solidFill>
+                  <a:srgbClr val="FFFFFF"/>
+                </a:solidFill>
+                <a:latin typeface="Calibri"/>
+              </a:rPr>
+              <a:t>2</a:t>
+            </a:r>
+          </a:p>
+        </p:txBody>
+      </p:sp>
+      <p:sp>
+        <p:nvSpPr>
+          <p:cNvPr id="12" name="TextBox 11"/>
+          <p:cNvSpPr txBox="1"/>
+          <p:nvPr/>
+        </p:nvSpPr>
+        <p:spPr>
+          <a:xfrm>
+            <a:off x="4892040" y="1554480"/>
+            <a:ext cx="2926080" cy="411480"/>
+          </a:xfrm>
+          <a:prstGeom prst="rect">
+            <a:avLst/>
+          </a:prstGeom>
+          <a:noFill/>
+        </p:spPr>
+        <p:txBody>
+          <a:bodyPr wrap="square" anchor="t" lIns="0" rIns="0" tIns="0" bIns="0">
+            <a:spAutoFit/>
+          </a:bodyPr>
+          <a:lstStyle/>
+          <a:p>
+            <a:pPr algn="l"/>
+            <a:r>
+              <a:rPr sz="1700" b="1" i="0">
+                <a:solidFill>
+                  <a:srgbClr val="0F1B2D"/>
+                </a:solidFill>
+                <a:latin typeface="Calibri"/>
+              </a:rPr>
+              <a:t>Predict unseen days</a:t>
+            </a:r>
+          </a:p>
+        </p:txBody>
+      </p:sp>
+      <p:sp>
+        <p:nvSpPr>
+          <p:cNvPr id="13" name="Rounded Rectangle 12"/>
+          <p:cNvSpPr/>
+          <p:nvPr/>
+        </p:nvSpPr>
+        <p:spPr>
+          <a:xfrm>
+            <a:off x="4297679" y="2148840"/>
+            <a:ext cx="3520440" cy="3566160"/>
+          </a:xfrm>
+          <a:prstGeom prst="roundRect">
+            <a:avLst>
+              <a:gd name="adj" fmla="val 5000"/>
+            </a:avLst>
+          </a:prstGeom>
+          <a:solidFill>
+            <a:srgbClr val="0F1B2D"/>
+          </a:solidFill>
+          <a:ln>
+            <a:noFill/>
+          </a:ln>
+          <a:effectLst/>
+        </p:spPr>
+        <p:style>
+          <a:lnRef idx="1">
+            <a:schemeClr val="accent1"/>
+          </a:lnRef>
+          <a:fillRef idx="3">
+            <a:schemeClr val="accent1"/>
+          </a:fillRef>
+          <a:effectRef idx="2">
+            <a:schemeClr val="accent1"/>
+          </a:effectRef>
+          <a:fontRef idx="minor">
+            <a:schemeClr val="lt1"/>
+          </a:fontRef>
+        </p:style>
+        <p:txBody>
+          <a:bodyPr rtlCol="0" anchor="ctr"/>
+          <a:lstStyle/>
+          <a:p>
+            <a:pPr algn="ctr"/>
+          </a:p>
+        </p:txBody>
+      </p:sp>
+      <p:sp>
+        <p:nvSpPr>
+          <p:cNvPr id="14" name="TextBox 13"/>
+          <p:cNvSpPr txBox="1"/>
+          <p:nvPr/>
+        </p:nvSpPr>
+        <p:spPr>
+          <a:xfrm>
+            <a:off x="4480559" y="2286000"/>
+            <a:ext cx="3200400" cy="822960"/>
+          </a:xfrm>
+          <a:prstGeom prst="rect">
+            <a:avLst/>
+          </a:prstGeom>
+          <a:noFill/>
+        </p:spPr>
+        <p:txBody>
+          <a:bodyPr wrap="square" anchor="t" lIns="0" rIns="0" tIns="0" bIns="0">
+            <a:spAutoFit/>
+          </a:bodyPr>
+          <a:lstStyle/>
+          <a:p>
+            <a:pPr algn="l"/>
+            <a:r>
+              <a:rPr sz="1200" b="0" i="0">
+                <a:solidFill>
+                  <a:srgbClr val="BFD4F2"/>
+                </a:solidFill>
+                <a:latin typeface="Courier New"/>
+              </a:rPr>
+              <a:t>$ python scripts/predict.py --demo --subject S1</a:t>
+            </a:r>
+          </a:p>
+        </p:txBody>
+      </p:sp>
+      <p:sp>
+        <p:nvSpPr>
+          <p:cNvPr id="15" name="TextBox 14"/>
+          <p:cNvSpPr txBox="1"/>
+          <p:nvPr/>
+        </p:nvSpPr>
+        <p:spPr>
+          <a:xfrm>
+            <a:off x="4480559" y="3154680"/>
+            <a:ext cx="3200400" cy="2468880"/>
+          </a:xfrm>
+          <a:prstGeom prst="rect">
+            <a:avLst/>
+          </a:prstGeom>
+          <a:noFill/>
+        </p:spPr>
+        <p:txBody>
+          <a:bodyPr wrap="square" anchor="t" lIns="0" rIns="0" tIns="0" bIns="0">
+            <a:spAutoFit/>
+          </a:bodyPr>
+          <a:lstStyle/>
+          <a:p>
+            <a:pPr algn="l"/>
+            <a:r>
+              <a:rPr sz="1200" b="0" i="0">
+                <a:solidFill>
+                  <a:srgbClr val="FFFFFF"/>
+                </a:solidFill>
+                <a:latin typeface="Courier New"/>
+              </a:rPr>
+              <a:t>day      MSE   %err      r</a:t>
+            </a:r>
+          </a:p>
+          <a:p>
+            <a:pPr algn="l"/>
+            <a:r>
+              <a:rPr sz="1200" b="0" i="0">
+                <a:solidFill>
+                  <a:srgbClr val="FFFFFF"/>
+                </a:solidFill>
+                <a:latin typeface="Courier New"/>
+              </a:rPr>
+              <a:t>  1   0.0286  16.9%   0.82</a:t>
+            </a:r>
+          </a:p>
+          <a:p>
+            <a:pPr algn="l"/>
+            <a:r>
+              <a:rPr sz="1200" b="0" i="0">
+                <a:solidFill>
+                  <a:srgbClr val="FFFFFF"/>
+                </a:solidFill>
+                <a:latin typeface="Courier New"/>
+              </a:rPr>
+              <a:t>  2   0.0191  13.8%   0.49</a:t>
+            </a:r>
+          </a:p>
+          <a:p>
+            <a:pPr algn="l"/>
+            <a:r>
+              <a:rPr sz="1200" b="0" i="0">
+                <a:solidFill>
+                  <a:srgbClr val="FFFFFF"/>
+                </a:solidFill>
+                <a:latin typeface="Courier New"/>
+              </a:rPr>
+              <a:t>  3   0.0132  11.5%   0.64</a:t>
+            </a:r>
+          </a:p>
+          <a:p>
+            <a:pPr algn="l"/>
+            <a:r>
+              <a:rPr sz="1200" b="0" i="0">
+                <a:solidFill>
+                  <a:srgbClr val="FFFFFF"/>
+                </a:solidFill>
+                <a:latin typeface="Courier New"/>
+              </a:rPr>
+              <a:t>  4   0.0119  10.9%   0.61</a:t>
+            </a:r>
+          </a:p>
+          <a:p>
+            <a:pPr algn="l"/>
+            <a:r>
+              <a:rPr sz="1200" b="0" i="0">
+                <a:solidFill>
+                  <a:srgbClr val="FFFFFF"/>
+                </a:solidFill>
+                <a:latin typeface="Courier New"/>
+              </a:rPr>
+              <a:t>  5   0.0149  12.2%   0.67</a:t>
+            </a:r>
+          </a:p>
+        </p:txBody>
+      </p:sp>
+      <p:sp>
+        <p:nvSpPr>
+          <p:cNvPr id="16" name="Oval 15"/>
+          <p:cNvSpPr/>
+          <p:nvPr/>
+        </p:nvSpPr>
+        <p:spPr>
+          <a:xfrm>
+            <a:off x="8046719" y="1508760"/>
+            <a:ext cx="457200" cy="457200"/>
+          </a:xfrm>
+          <a:prstGeom prst="ellipse">
+            <a:avLst/>
+          </a:prstGeom>
+          <a:solidFill>
+            <a:srgbClr val="2A78D6"/>
+          </a:solidFill>
+          <a:ln>
+            <a:noFill/>
+          </a:ln>
+        </p:spPr>
+        <p:style>
+          <a:lnRef idx="1">
+            <a:schemeClr val="accent1"/>
+          </a:lnRef>
+          <a:fillRef idx="3">
+            <a:schemeClr val="accent1"/>
+          </a:fillRef>
+          <a:effectRef idx="2">
+            <a:schemeClr val="accent1"/>
+          </a:effectRef>
+          <a:fontRef idx="minor">
+            <a:schemeClr val="lt1"/>
+          </a:fontRef>
+        </p:style>
+        <p:txBody>
+          <a:bodyPr rtlCol="0" anchor="ctr" lIns="0" rIns="0" tIns="0" bIns="0"/>
+          <a:lstStyle/>
+          <a:p>
+            <a:pPr algn="ctr"/>
+            <a:r>
+              <a:rPr sz="1600" b="1">
+                <a:solidFill>
+                  <a:srgbClr val="FFFFFF"/>
+                </a:solidFill>
+                <a:latin typeface="Calibri"/>
+              </a:rPr>
+              <a:t>3</a:t>
+            </a:r>
+          </a:p>
+        </p:txBody>
+      </p:sp>
+      <p:sp>
+        <p:nvSpPr>
+          <p:cNvPr id="17" name="TextBox 16"/>
+          <p:cNvSpPr txBox="1"/>
+          <p:nvPr/>
+        </p:nvSpPr>
+        <p:spPr>
+          <a:xfrm>
+            <a:off x="8641080" y="1554480"/>
+            <a:ext cx="2926080" cy="411480"/>
+          </a:xfrm>
+          <a:prstGeom prst="rect">
+            <a:avLst/>
+          </a:prstGeom>
+          <a:noFill/>
+        </p:spPr>
+        <p:txBody>
+          <a:bodyPr wrap="square" anchor="t" lIns="0" rIns="0" tIns="0" bIns="0">
+            <a:spAutoFit/>
+          </a:bodyPr>
+          <a:lstStyle/>
+          <a:p>
+            <a:pPr algn="l"/>
+            <a:r>
+              <a:rPr sz="1700" b="1" i="0">
+                <a:solidFill>
+                  <a:srgbClr val="0F1B2D"/>
+                </a:solidFill>
+                <a:latin typeface="Calibri"/>
+              </a:rPr>
+              <a:t>Automated tests</a:t>
+            </a:r>
+          </a:p>
+        </p:txBody>
+      </p:sp>
+      <p:sp>
+        <p:nvSpPr>
+          <p:cNvPr id="18" name="Rounded Rectangle 17"/>
+          <p:cNvSpPr/>
+          <p:nvPr/>
+        </p:nvSpPr>
+        <p:spPr>
+          <a:xfrm>
+            <a:off x="8046719" y="2148840"/>
+            <a:ext cx="3520440" cy="3566160"/>
+          </a:xfrm>
+          <a:prstGeom prst="roundRect">
+            <a:avLst>
+              <a:gd name="adj" fmla="val 5000"/>
+            </a:avLst>
+          </a:prstGeom>
+          <a:solidFill>
+            <a:srgbClr val="0F1B2D"/>
+          </a:solidFill>
+          <a:ln>
+            <a:noFill/>
+          </a:ln>
+          <a:effectLst/>
+        </p:spPr>
+        <p:style>
+          <a:lnRef idx="1">
+            <a:schemeClr val="accent1"/>
+          </a:lnRef>
+          <a:fillRef idx="3">
+            <a:schemeClr val="accent1"/>
+          </a:fillRef>
+          <a:effectRef idx="2">
+            <a:schemeClr val="accent1"/>
+          </a:effectRef>
+          <a:fontRef idx="minor">
+            <a:schemeClr val="lt1"/>
+          </a:fontRef>
+        </p:style>
+        <p:txBody>
+          <a:bodyPr rtlCol="0" anchor="ctr"/>
+          <a:lstStyle/>
+          <a:p>
+            <a:pPr algn="ctr"/>
+          </a:p>
+        </p:txBody>
+      </p:sp>
+      <p:sp>
+        <p:nvSpPr>
+          <p:cNvPr id="19" name="TextBox 18"/>
+          <p:cNvSpPr txBox="1"/>
+          <p:nvPr/>
+        </p:nvSpPr>
+        <p:spPr>
+          <a:xfrm>
+            <a:off x="8229599" y="2286000"/>
+            <a:ext cx="3200400" cy="822960"/>
+          </a:xfrm>
+          <a:prstGeom prst="rect">
+            <a:avLst/>
+          </a:prstGeom>
+          <a:noFill/>
+        </p:spPr>
+        <p:txBody>
+          <a:bodyPr wrap="square" anchor="t" lIns="0" rIns="0" tIns="0" bIns="0">
+            <a:spAutoFit/>
+          </a:bodyPr>
+          <a:lstStyle/>
+          <a:p>
+            <a:pPr algn="l"/>
+            <a:r>
+              <a:rPr sz="1200" b="0" i="0">
+                <a:solidFill>
+                  <a:srgbClr val="BFD4F2"/>
+                </a:solidFill>
+                <a:latin typeface="Courier New"/>
+              </a:rPr>
+              <a:t>$ python -m pytest -q</a:t>
+            </a:r>
+          </a:p>
+        </p:txBody>
+      </p:sp>
+      <p:sp>
+        <p:nvSpPr>
+          <p:cNvPr id="20" name="TextBox 19"/>
+          <p:cNvSpPr txBox="1"/>
+          <p:nvPr/>
+        </p:nvSpPr>
+        <p:spPr>
+          <a:xfrm>
+            <a:off x="8229599" y="3154680"/>
+            <a:ext cx="3200400" cy="2468880"/>
+          </a:xfrm>
+          <a:prstGeom prst="rect">
+            <a:avLst/>
+          </a:prstGeom>
+          <a:noFill/>
+        </p:spPr>
+        <p:txBody>
+          <a:bodyPr wrap="square" anchor="t" lIns="0" rIns="0" tIns="0" bIns="0">
+            <a:spAutoFit/>
+          </a:bodyPr>
+          <a:lstStyle/>
+          <a:p>
+            <a:pPr algn="l"/>
+            <a:r>
+              <a:rPr sz="1200" b="0" i="0">
+                <a:solidFill>
+                  <a:srgbClr val="FFFFFF"/>
+                </a:solidFill>
+                <a:latin typeface="Courier New"/>
+              </a:rPr>
+              <a:t>..........</a:t>
+            </a:r>
+          </a:p>
+          <a:p>
+            <a:pPr algn="l"/>
+            <a:r>
+              <a:rPr sz="1200" b="0" i="0">
+                <a:solidFill>
+                  <a:srgbClr val="FFFFFF"/>
+                </a:solidFill>
+                <a:latin typeface="Courier New"/>
+              </a:rPr>
+              <a:t>10 passed</a:t>
+            </a:r>
+          </a:p>
+        </p:txBody>
+      </p:sp>
+      <p:sp>
+        <p:nvSpPr>
+          <p:cNvPr id="21" name="TextBox 20"/>
+          <p:cNvSpPr txBox="1"/>
+          <p:nvPr/>
+        </p:nvSpPr>
+        <p:spPr>
+          <a:xfrm>
+            <a:off x="548640" y="5897880"/>
+            <a:ext cx="11064240" cy="365760"/>
+          </a:xfrm>
+          <a:prstGeom prst="rect">
+            <a:avLst/>
+          </a:prstGeom>
+          <a:noFill/>
+        </p:spPr>
+        <p:txBody>
+          <a:bodyPr wrap="square" anchor="t" lIns="0" rIns="0" tIns="0" bIns="0">
+            <a:spAutoFit/>
+          </a:bodyPr>
+          <a:lstStyle/>
+          <a:p>
+            <a:pPr algn="l"/>
+            <a:r>
+              <a:rPr sz="1300" b="0" i="1">
+                <a:solidFill>
+                  <a:srgbClr val="555B66"/>
+                </a:solidFill>
+                <a:latin typeface="Calibri"/>
+              </a:rPr>
+              <a:t>Run from the project folder:  cd "ML proj"   ·   total time under a minute</a:t>
             </a:r>
           </a:p>
         </p:txBody>
@@ -7868,239 +8003,80 @@
       </p:sp>
       <p:sp>
         <p:nvSpPr>
-          <p:cNvPr id="4" name="Rounded Rectangle 3"/>
-          <p:cNvSpPr/>
+          <p:cNvPr id="4" name="TextBox 3"/>
+          <p:cNvSpPr txBox="1"/>
           <p:nvPr/>
         </p:nvSpPr>
         <p:spPr>
           <a:xfrm>
             <a:off x="548640" y="3291840"/>
-            <a:ext cx="5440680" cy="2011680"/>
-          </a:xfrm>
-          <a:prstGeom prst="roundRect">
-            <a:avLst>
-              <a:gd name="adj" fmla="val 8000"/>
-            </a:avLst>
-          </a:prstGeom>
-          <a:solidFill>
-            <a:srgbClr val="1C2C45"/>
-          </a:solidFill>
-          <a:ln>
-            <a:noFill/>
-          </a:ln>
-          <a:effectLst/>
-        </p:spPr>
-        <p:style>
-          <a:lnRef idx="1">
-            <a:schemeClr val="accent1"/>
-          </a:lnRef>
-          <a:fillRef idx="3">
-            <a:schemeClr val="accent1"/>
-          </a:fillRef>
-          <a:effectRef idx="2">
-            <a:schemeClr val="accent1"/>
-          </a:effectRef>
-          <a:fontRef idx="minor">
-            <a:schemeClr val="lt1"/>
-          </a:fontRef>
-        </p:style>
-        <p:txBody>
-          <a:bodyPr rtlCol="0" anchor="ctr"/>
-          <a:lstStyle/>
-          <a:p>
-            <a:pPr algn="ctr"/>
+            <a:ext cx="10972800" cy="914400"/>
+          </a:xfrm>
+          <a:prstGeom prst="rect">
+            <a:avLst/>
+          </a:prstGeom>
+          <a:noFill/>
+        </p:spPr>
+        <p:txBody>
+          <a:bodyPr wrap="square" anchor="t" lIns="0" rIns="0" tIns="0" bIns="0">
+            <a:spAutoFit/>
+          </a:bodyPr>
+          <a:lstStyle/>
+          <a:p>
+            <a:pPr algn="l">
+              <a:spcAft>
+                <a:spcPts val="800"/>
+              </a:spcAft>
+            </a:pPr>
+            <a:r>
+              <a:rPr sz="2000" b="1" i="0">
+                <a:solidFill>
+                  <a:srgbClr val="FFFFFF"/>
+                </a:solidFill>
+                <a:latin typeface="Calibri"/>
+              </a:rPr>
+              <a:t>Mukil Skanda A</a:t>
+            </a:r>
+            <a:r>
+              <a:rPr sz="2000" b="0" i="0">
+                <a:solidFill>
+                  <a:srgbClr val="BFD4F2"/>
+                </a:solidFill>
+                <a:latin typeface="Calibri"/>
+              </a:rPr>
+              <a:t>  ·  PES1UG24CS281</a:t>
+            </a:r>
+          </a:p>
+          <a:p>
+            <a:pPr algn="l">
+              <a:spcAft>
+                <a:spcPts val="800"/>
+              </a:spcAft>
+            </a:pPr>
+            <a:r>
+              <a:rPr sz="2000" b="1" i="0">
+                <a:solidFill>
+                  <a:srgbClr val="FFFFFF"/>
+                </a:solidFill>
+                <a:latin typeface="Calibri"/>
+              </a:rPr>
+              <a:t>Likhith M</a:t>
+            </a:r>
+            <a:r>
+              <a:rPr sz="2000" b="0" i="0">
+                <a:solidFill>
+                  <a:srgbClr val="BFD4F2"/>
+                </a:solidFill>
+                <a:latin typeface="Calibri"/>
+              </a:rPr>
+              <a:t>  ·  PES1UG24CS282</a:t>
+            </a:r>
           </a:p>
         </p:txBody>
       </p:sp>
       <p:sp>
         <p:nvSpPr>
           <p:cNvPr id="5" name="TextBox 4"/>
-          <p:cNvSpPr txBox="1"/>
-          <p:nvPr/>
-        </p:nvSpPr>
-        <p:spPr>
-          <a:xfrm>
-            <a:off x="822959" y="3474720"/>
-            <a:ext cx="4937760" cy="457200"/>
-          </a:xfrm>
-          <a:prstGeom prst="rect">
-            <a:avLst/>
-          </a:prstGeom>
-          <a:noFill/>
-        </p:spPr>
-        <p:txBody>
-          <a:bodyPr wrap="square" anchor="t" lIns="0" rIns="0" tIns="0" bIns="0">
-            <a:spAutoFit/>
-          </a:bodyPr>
-          <a:lstStyle/>
-          <a:p>
-            <a:pPr algn="l"/>
-            <a:r>
-              <a:rPr sz="2000" b="1" i="0">
-                <a:solidFill>
-                  <a:srgbClr val="EB6834"/>
-                </a:solidFill>
-                <a:latin typeface="Calibri"/>
-              </a:rPr>
-              <a:t>Mukil Skanda A · PES1UG24CS281</a:t>
-            </a:r>
-          </a:p>
-        </p:txBody>
-      </p:sp>
-      <p:sp>
-        <p:nvSpPr>
-          <p:cNvPr id="6" name="TextBox 5"/>
-          <p:cNvSpPr txBox="1"/>
-          <p:nvPr/>
-        </p:nvSpPr>
-        <p:spPr>
-          <a:xfrm>
-            <a:off x="822959" y="4023360"/>
-            <a:ext cx="4937760" cy="1188720"/>
-          </a:xfrm>
-          <a:prstGeom prst="rect">
-            <a:avLst/>
-          </a:prstGeom>
-          <a:noFill/>
-        </p:spPr>
-        <p:txBody>
-          <a:bodyPr wrap="square" anchor="t" lIns="0" rIns="0" tIns="0" bIns="0">
-            <a:spAutoFit/>
-          </a:bodyPr>
-          <a:lstStyle/>
-          <a:p>
-            <a:pPr algn="l"/>
-            <a:r>
-              <a:rPr sz="1500" b="0" i="0">
-                <a:solidFill>
-                  <a:srgbClr val="FFFFFF"/>
-                </a:solidFill>
-                <a:latin typeface="Calibri"/>
-              </a:rPr>
-              <a:t>Extended study: Bayesian-regularised NN, 13-model zoo, nested &amp; leave-one-day-out validation, calibration, dashboard, write-up</a:t>
-            </a:r>
-          </a:p>
-        </p:txBody>
-      </p:sp>
-      <p:sp>
-        <p:nvSpPr>
-          <p:cNvPr id="7" name="Rounded Rectangle 6"/>
-          <p:cNvSpPr/>
-          <p:nvPr/>
-        </p:nvSpPr>
-        <p:spPr>
-          <a:xfrm>
-            <a:off x="6217920" y="3291840"/>
-            <a:ext cx="5440680" cy="2011680"/>
-          </a:xfrm>
-          <a:prstGeom prst="roundRect">
-            <a:avLst>
-              <a:gd name="adj" fmla="val 8000"/>
-            </a:avLst>
-          </a:prstGeom>
-          <a:solidFill>
-            <a:srgbClr val="1C2C45"/>
-          </a:solidFill>
-          <a:ln>
-            <a:noFill/>
-          </a:ln>
-          <a:effectLst/>
-        </p:spPr>
-        <p:style>
-          <a:lnRef idx="1">
-            <a:schemeClr val="accent1"/>
-          </a:lnRef>
-          <a:fillRef idx="3">
-            <a:schemeClr val="accent1"/>
-          </a:fillRef>
-          <a:effectRef idx="2">
-            <a:schemeClr val="accent1"/>
-          </a:effectRef>
-          <a:fontRef idx="minor">
-            <a:schemeClr val="lt1"/>
-          </a:fontRef>
-        </p:style>
-        <p:txBody>
-          <a:bodyPr rtlCol="0" anchor="ctr"/>
-          <a:lstStyle/>
-          <a:p>
-            <a:pPr algn="ctr"/>
-          </a:p>
-        </p:txBody>
-      </p:sp>
-      <p:sp>
-        <p:nvSpPr>
-          <p:cNvPr id="8" name="TextBox 7"/>
-          <p:cNvSpPr txBox="1"/>
-          <p:nvPr/>
-        </p:nvSpPr>
-        <p:spPr>
-          <a:xfrm>
-            <a:off x="6492240" y="3474720"/>
-            <a:ext cx="4937760" cy="457200"/>
-          </a:xfrm>
-          <a:prstGeom prst="rect">
-            <a:avLst/>
-          </a:prstGeom>
-          <a:noFill/>
-        </p:spPr>
-        <p:txBody>
-          <a:bodyPr wrap="square" anchor="t" lIns="0" rIns="0" tIns="0" bIns="0">
-            <a:spAutoFit/>
-          </a:bodyPr>
-          <a:lstStyle/>
-          <a:p>
-            <a:pPr algn="l"/>
-            <a:r>
-              <a:rPr sz="2000" b="1" i="0">
-                <a:solidFill>
-                  <a:srgbClr val="EB6834"/>
-                </a:solidFill>
-                <a:latin typeface="Calibri"/>
-              </a:rPr>
-              <a:t>Likhith M · PES1UG24CS282</a:t>
-            </a:r>
-          </a:p>
-        </p:txBody>
-      </p:sp>
-      <p:sp>
-        <p:nvSpPr>
-          <p:cNvPr id="9" name="TextBox 8"/>
-          <p:cNvSpPr txBox="1"/>
-          <p:nvPr/>
-        </p:nvSpPr>
-        <p:spPr>
-          <a:xfrm>
-            <a:off x="6492240" y="4023360"/>
-            <a:ext cx="4937760" cy="1188720"/>
-          </a:xfrm>
-          <a:prstGeom prst="rect">
-            <a:avLst/>
-          </a:prstGeom>
-          <a:noFill/>
-        </p:spPr>
-        <p:txBody>
-          <a:bodyPr wrap="square" anchor="t" lIns="0" rIns="0" tIns="0" bIns="0">
-            <a:spAutoFit/>
-          </a:bodyPr>
-          <a:lstStyle/>
-          <a:p>
-            <a:pPr algn="l"/>
-            <a:r>
-              <a:rPr sz="1500" b="0" i="0">
-                <a:solidFill>
-                  <a:srgbClr val="FFFFFF"/>
-                </a:solidFill>
-                <a:latin typeface="Calibri"/>
-              </a:rPr>
-              <a:t>Faithful MATLAB → Python port of the paper (paper_reproduction/): NN vs linear-regression baseline, 4 feature sets, forward selection, GitHub repo</a:t>
-            </a:r>
-          </a:p>
-        </p:txBody>
-      </p:sp>
-      <p:sp>
-        <p:nvSpPr>
-          <p:cNvPr id="10" name="TextBox 9"/>
           <p:cNvSpPr txBox="1"/>
           <p:nvPr/>
         </p:nvSpPr>

</xml_diff>

<commit_message>
Final slide: Thank you
</commit_message>
<xml_diff>
--- a/docs/MetaCost_Presentation.pptx
+++ b/docs/MetaCost_Presentation.pptx
@@ -18,8 +18,6 @@
     <p:sldId id="266" r:id="rId18"/>
     <p:sldId id="267" r:id="rId19"/>
     <p:sldId id="268" r:id="rId20"/>
-    <p:sldId id="269" r:id="rId21"/>
-    <p:sldId id="270" r:id="rId22"/>
   </p:sldIdLst>
   <p:sldSz cx="12191695" cy="6858000" type="screen4x3"/>
   <p:notesSz cx="6858000" cy="9144000"/>
@@ -796,147 +794,7 @@
           <a:lstStyle/>
           <a:p>
             <a:r>
-              <a:t>Thank the panel and invite questions.</a:t>
-            </a:r>
-          </a:p>
-        </p:txBody>
-      </p:sp>
-      <p:sp>
-        <p:nvSpPr>
-          <p:cNvPr id="4" name="Slide Number Placeholder 3"/>
-          <p:cNvSpPr>
-            <a:spLocks noGrp="1"/>
-          </p:cNvSpPr>
-          <p:nvPr>
-            <p:ph type="sldNum" idx="5" sz="quarter"/>
-          </p:nvPr>
-        </p:nvSpPr>
-        <p:spPr/>
-      </p:sp>
-    </p:spTree>
-  </p:cSld>
-  <p:clrMapOvr>
-    <a:masterClrMapping/>
-  </p:clrMapOvr>
-</p:notes>
-</file>
-
-<file path=ppt/notesSlides/notesSlide14.xml><?xml version="1.0" encoding="utf-8"?>
-<p:notes xmlns:a="http://schemas.openxmlformats.org/drawingml/2006/main" xmlns:p="http://schemas.openxmlformats.org/presentationml/2006/main" xmlns:r="http://schemas.openxmlformats.org/officeDocument/2006/relationships">
-  <p:cSld>
-    <p:spTree>
-      <p:nvGrpSpPr>
-        <p:cNvPr id="1" name=""/>
-        <p:cNvGrpSpPr/>
-        <p:nvPr/>
-      </p:nvGrpSpPr>
-      <p:grpSpPr>
-        <a:xfrm>
-          <a:off x="0" y="0"/>
-          <a:ext cx="0" cy="0"/>
-          <a:chOff x="0" y="0"/>
-          <a:chExt cx="0" cy="0"/>
-        </a:xfrm>
-      </p:grpSpPr>
-      <p:sp>
-        <p:nvSpPr>
-          <p:cNvPr id="2" name="Slide Image Placeholder 1"/>
-          <p:cNvSpPr>
-            <a:spLocks noGrp="1"/>
-          </p:cNvSpPr>
-          <p:nvPr>
-            <p:ph type="sldImg" idx="2"/>
-          </p:nvPr>
-        </p:nvSpPr>
-        <p:spPr/>
-      </p:sp>
-      <p:sp>
-        <p:nvSpPr>
-          <p:cNvPr id="3" name="Notes Placeholder 2"/>
-          <p:cNvSpPr>
-            <a:spLocks noGrp="1"/>
-          </p:cNvSpPr>
-          <p:nvPr>
-            <p:ph type="body" idx="3" sz="quarter"/>
-          </p:nvPr>
-        </p:nvSpPr>
-        <p:spPr/>
-        <p:txBody>
-          <a:bodyPr/>
-          <a:lstStyle/>
-          <a:p>
-            <a:r>
-              <a:t>Left: PCA ignores the target. Supervised PLS with one component matches PCA with 8 on S2, which explains the paper's poor PCA result. Right: train on one person, test on the other: worse than predicting the mean. Per-subject z-scoring cuts the error 3x but is still not useful, so models must be subject-specific (or need many more subjects plus anthropometrics).</a:t>
-            </a:r>
-          </a:p>
-        </p:txBody>
-      </p:sp>
-      <p:sp>
-        <p:nvSpPr>
-          <p:cNvPr id="4" name="Slide Number Placeholder 3"/>
-          <p:cNvSpPr>
-            <a:spLocks noGrp="1"/>
-          </p:cNvSpPr>
-          <p:nvPr>
-            <p:ph type="sldNum" idx="5" sz="quarter"/>
-          </p:nvPr>
-        </p:nvSpPr>
-        <p:spPr/>
-      </p:sp>
-    </p:spTree>
-  </p:cSld>
-  <p:clrMapOvr>
-    <a:masterClrMapping/>
-  </p:clrMapOvr>
-</p:notes>
-</file>
-
-<file path=ppt/notesSlides/notesSlide15.xml><?xml version="1.0" encoding="utf-8"?>
-<p:notes xmlns:a="http://schemas.openxmlformats.org/drawingml/2006/main" xmlns:p="http://schemas.openxmlformats.org/presentationml/2006/main" xmlns:r="http://schemas.openxmlformats.org/officeDocument/2006/relationships">
-  <p:cSld>
-    <p:spTree>
-      <p:nvGrpSpPr>
-        <p:cNvPr id="1" name=""/>
-        <p:cNvGrpSpPr/>
-        <p:nvPr/>
-      </p:nvGrpSpPr>
-      <p:grpSpPr>
-        <a:xfrm>
-          <a:off x="0" y="0"/>
-          <a:ext cx="0" cy="0"/>
-          <a:chOff x="0" y="0"/>
-          <a:chExt cx="0" cy="0"/>
-        </a:xfrm>
-      </p:grpSpPr>
-      <p:sp>
-        <p:nvSpPr>
-          <p:cNvPr id="2" name="Slide Image Placeholder 1"/>
-          <p:cNvSpPr>
-            <a:spLocks noGrp="1"/>
-          </p:cNvSpPr>
-          <p:nvPr>
-            <p:ph type="sldImg" idx="2"/>
-          </p:nvPr>
-        </p:nvSpPr>
-        <p:spPr/>
-      </p:sp>
-      <p:sp>
-        <p:nvSpPr>
-          <p:cNvPr id="3" name="Notes Placeholder 2"/>
-          <p:cNvSpPr>
-            <a:spLocks noGrp="1"/>
-          </p:cNvSpPr>
-          <p:nvPr>
-            <p:ph type="body" idx="3" sz="quarter"/>
-          </p:nvPr>
-        </p:nvSpPr>
-        <p:spPr/>
-        <p:txBody>
-          <a:bodyPr/>
-          <a:lstStyle/>
-          <a:p>
-            <a:r>
-              <a:t>Calibration: the GP's nominal 95% interval covers 94% of unseen-day points for S1, close to perfect. For S2 it covers 77%, so it is over-confident on the harder subject, but the intervals are visibly wider there. Learning curves are still falling for S1 at 144 samples: more sessions should keep improving accuracy.</a:t>
+              <a:t>Thank the panel.</a:t>
             </a:r>
           </a:p>
         </p:txBody>
@@ -7099,7 +6957,7 @@
                 </a:solidFill>
                 <a:latin typeface="Cambria"/>
               </a:rPr>
-              <a:t>Thank you, questions?</a:t>
+              <a:t>Thank you</a:t>
             </a:r>
           </a:p>
         </p:txBody>
@@ -7243,868 +7101,6 @@
                 <a:latin typeface="Calibri"/>
               </a:rPr>
               <a:t>Ref: Krimsky &amp; Ng, CS229 2018 · Zhang et al., Science 2017 · MacKay 1992 · Rasmussen &amp; Williams 2006</a:t>
-            </a:r>
-          </a:p>
-        </p:txBody>
-      </p:sp>
-    </p:spTree>
-  </p:cSld>
-  <p:clrMapOvr>
-    <a:masterClrMapping/>
-  </p:clrMapOvr>
-</p:sld>
-</file>
-
-<file path=ppt/slides/slide14.xml><?xml version="1.0" encoding="utf-8"?>
-<p:sld xmlns:a="http://schemas.openxmlformats.org/drawingml/2006/main" xmlns:p="http://schemas.openxmlformats.org/presentationml/2006/main" xmlns:r="http://schemas.openxmlformats.org/officeDocument/2006/relationships">
-  <p:cSld>
-    <p:bg>
-      <p:bgPr>
-        <a:solidFill>
-          <a:srgbClr val="FFFFFF"/>
-        </a:solidFill>
-        <a:effectLst/>
-      </p:bgPr>
-    </p:bg>
-    <p:spTree>
-      <p:nvGrpSpPr>
-        <p:cNvPr id="1" name=""/>
-        <p:cNvGrpSpPr/>
-        <p:nvPr/>
-      </p:nvGrpSpPr>
-      <p:grpSpPr/>
-      <p:sp>
-        <p:nvSpPr>
-          <p:cNvPr id="2" name="TextBox 1"/>
-          <p:cNvSpPr txBox="1"/>
-          <p:nvPr/>
-        </p:nvSpPr>
-        <p:spPr>
-          <a:xfrm>
-            <a:off x="548640" y="347472"/>
-            <a:ext cx="9144000" cy="274320"/>
-          </a:xfrm>
-          <a:prstGeom prst="rect">
-            <a:avLst/>
-          </a:prstGeom>
-          <a:noFill/>
-        </p:spPr>
-        <p:txBody>
-          <a:bodyPr wrap="square" anchor="t" lIns="0" rIns="0" tIns="0" bIns="0">
-            <a:spAutoFit/>
-          </a:bodyPr>
-          <a:lstStyle/>
-          <a:p>
-            <a:pPr algn="l"/>
-            <a:r>
-              <a:rPr sz="1200" b="1" i="0">
-                <a:solidFill>
-                  <a:srgbClr val="2A78D6"/>
-                </a:solidFill>
-                <a:latin typeface="Calibri"/>
-              </a:rPr>
-              <a:t>BACKUP · DEEPER ANALYSIS</a:t>
-            </a:r>
-          </a:p>
-        </p:txBody>
-      </p:sp>
-      <p:sp>
-        <p:nvSpPr>
-          <p:cNvPr id="3" name="TextBox 2"/>
-          <p:cNvSpPr txBox="1"/>
-          <p:nvPr/>
-        </p:nvSpPr>
-        <p:spPr>
-          <a:xfrm>
-            <a:off x="548640" y="621792"/>
-            <a:ext cx="11064240" cy="731520"/>
-          </a:xfrm>
-          <a:prstGeom prst="rect">
-            <a:avLst/>
-          </a:prstGeom>
-          <a:noFill/>
-        </p:spPr>
-        <p:txBody>
-          <a:bodyPr wrap="square" anchor="t" lIns="0" rIns="0" tIns="0" bIns="0">
-            <a:spAutoFit/>
-          </a:bodyPr>
-          <a:lstStyle/>
-          <a:p>
-            <a:pPr algn="l"/>
-            <a:r>
-              <a:rPr sz="3000" b="1" i="0">
-                <a:solidFill>
-                  <a:srgbClr val="0F1B2D"/>
-                </a:solidFill>
-                <a:latin typeface="Cambria"/>
-              </a:rPr>
-              <a:t>Why PCA failed, and why one model cannot fit everyone</a:t>
-            </a:r>
-          </a:p>
-        </p:txBody>
-      </p:sp>
-      <p:sp>
-        <p:nvSpPr>
-          <p:cNvPr id="4" name="TextBox 3"/>
-          <p:cNvSpPr txBox="1"/>
-          <p:nvPr/>
-        </p:nvSpPr>
-        <p:spPr>
-          <a:xfrm>
-            <a:off x="548640" y="6419088"/>
-            <a:ext cx="7315200" cy="274320"/>
-          </a:xfrm>
-          <a:prstGeom prst="rect">
-            <a:avLst/>
-          </a:prstGeom>
-          <a:noFill/>
-        </p:spPr>
-        <p:txBody>
-          <a:bodyPr wrap="square" anchor="t" lIns="0" rIns="0" tIns="0" bIns="0">
-            <a:spAutoFit/>
-          </a:bodyPr>
-          <a:lstStyle/>
-          <a:p>
-            <a:pPr algn="l"/>
-            <a:r>
-              <a:rPr sz="1000" b="0" i="0">
-                <a:solidFill>
-                  <a:srgbClr val="555B66"/>
-                </a:solidFill>
-                <a:latin typeface="Calibri"/>
-              </a:rPr>
-              <a:t>MetaCost · Predicting metabolic cost during HILO</a:t>
-            </a:r>
-          </a:p>
-        </p:txBody>
-      </p:sp>
-      <p:sp>
-        <p:nvSpPr>
-          <p:cNvPr id="5" name="TextBox 4"/>
-          <p:cNvSpPr txBox="1"/>
-          <p:nvPr/>
-        </p:nvSpPr>
-        <p:spPr>
-          <a:xfrm>
-            <a:off x="10972800" y="6419088"/>
-            <a:ext cx="667512" cy="274320"/>
-          </a:xfrm>
-          <a:prstGeom prst="rect">
-            <a:avLst/>
-          </a:prstGeom>
-          <a:noFill/>
-        </p:spPr>
-        <p:txBody>
-          <a:bodyPr wrap="square" anchor="t" lIns="0" rIns="0" tIns="0" bIns="0">
-            <a:spAutoFit/>
-          </a:bodyPr>
-          <a:lstStyle/>
-          <a:p>
-            <a:pPr algn="r"/>
-            <a:r>
-              <a:rPr sz="1000" b="0" i="0">
-                <a:solidFill>
-                  <a:srgbClr val="555B66"/>
-                </a:solidFill>
-                <a:latin typeface="Calibri"/>
-              </a:rPr>
-              <a:t>14</a:t>
-            </a:r>
-          </a:p>
-        </p:txBody>
-      </p:sp>
-      <p:pic>
-        <p:nvPicPr>
-          <p:cNvPr id="6" name="Picture 5" descr="F9_dimensionality_reduction.png"/>
-          <p:cNvPicPr>
-            <a:picLocks noChangeAspect="1"/>
-          </p:cNvPicPr>
-          <p:nvPr/>
-        </p:nvPicPr>
-        <p:blipFill>
-          <a:blip r:embed="rId3"/>
-          <a:stretch>
-            <a:fillRect/>
-          </a:stretch>
-        </p:blipFill>
-        <p:spPr>
-          <a:xfrm>
-            <a:off x="457200" y="1837943"/>
-            <a:ext cx="5669280" cy="2267712"/>
-          </a:xfrm>
-          <a:prstGeom prst="rect">
-            <a:avLst/>
-          </a:prstGeom>
-        </p:spPr>
-      </p:pic>
-      <p:pic>
-        <p:nvPicPr>
-          <p:cNvPr id="7" name="Picture 6" descr="F12_cross_subject.png"/>
-          <p:cNvPicPr>
-            <a:picLocks noChangeAspect="1"/>
-          </p:cNvPicPr>
-          <p:nvPr/>
-        </p:nvPicPr>
-        <p:blipFill>
-          <a:blip r:embed="rId4"/>
-          <a:stretch>
-            <a:fillRect/>
-          </a:stretch>
-        </p:blipFill>
-        <p:spPr>
-          <a:xfrm>
-            <a:off x="6309360" y="1623060"/>
-            <a:ext cx="5394960" cy="2697480"/>
-          </a:xfrm>
-          <a:prstGeom prst="rect">
-            <a:avLst/>
-          </a:prstGeom>
-        </p:spPr>
-      </p:pic>
-      <p:sp>
-        <p:nvSpPr>
-          <p:cNvPr id="8" name="Rounded Rectangle 7"/>
-          <p:cNvSpPr/>
-          <p:nvPr/>
-        </p:nvSpPr>
-        <p:spPr>
-          <a:xfrm>
-            <a:off x="548640" y="4754880"/>
-            <a:ext cx="5440680" cy="1463040"/>
-          </a:xfrm>
-          <a:prstGeom prst="roundRect">
-            <a:avLst>
-              <a:gd name="adj" fmla="val 8000"/>
-            </a:avLst>
-          </a:prstGeom>
-          <a:solidFill>
-            <a:srgbClr val="F1F5FB"/>
-          </a:solidFill>
-          <a:ln>
-            <a:noFill/>
-          </a:ln>
-          <a:effectLst/>
-        </p:spPr>
-        <p:style>
-          <a:lnRef idx="1">
-            <a:schemeClr val="accent1"/>
-          </a:lnRef>
-          <a:fillRef idx="3">
-            <a:schemeClr val="accent1"/>
-          </a:fillRef>
-          <a:effectRef idx="2">
-            <a:schemeClr val="accent1"/>
-          </a:effectRef>
-          <a:fontRef idx="minor">
-            <a:schemeClr val="lt1"/>
-          </a:fontRef>
-        </p:style>
-        <p:txBody>
-          <a:bodyPr rtlCol="0" anchor="ctr"/>
-          <a:lstStyle/>
-          <a:p>
-            <a:pPr algn="ctr"/>
-          </a:p>
-        </p:txBody>
-      </p:sp>
-      <p:sp>
-        <p:nvSpPr>
-          <p:cNvPr id="9" name="TextBox 8"/>
-          <p:cNvSpPr txBox="1"/>
-          <p:nvPr/>
-        </p:nvSpPr>
-        <p:spPr>
-          <a:xfrm>
-            <a:off x="777240" y="4873752"/>
-            <a:ext cx="5029200" cy="1280160"/>
-          </a:xfrm>
-          <a:prstGeom prst="rect">
-            <a:avLst/>
-          </a:prstGeom>
-          <a:noFill/>
-        </p:spPr>
-        <p:txBody>
-          <a:bodyPr wrap="square" anchor="t" lIns="0" rIns="0" tIns="0" bIns="0">
-            <a:spAutoFit/>
-          </a:bodyPr>
-          <a:lstStyle/>
-          <a:p>
-            <a:pPr algn="l">
-              <a:spcAft>
-                <a:spcPts val="400"/>
-              </a:spcAft>
-            </a:pPr>
-            <a:r>
-              <a:rPr sz="1700" b="1" i="0">
-                <a:solidFill>
-                  <a:srgbClr val="0F1B2D"/>
-                </a:solidFill>
-                <a:latin typeface="Calibri"/>
-              </a:rPr>
-              <a:t>Supervised &gt; unsupervised</a:t>
-            </a:r>
-          </a:p>
-          <a:p>
-            <a:pPr algn="l">
-              <a:spcAft>
-                <a:spcPts val="400"/>
-              </a:spcAft>
-            </a:pPr>
-            <a:r>
-              <a:rPr sz="1400" b="0" i="0">
-                <a:solidFill>
-                  <a:srgbClr val="555B66"/>
-                </a:solidFill>
-                <a:latin typeface="Calibri"/>
-              </a:rPr>
-              <a:t>1 PLS component (0.0138) = 8 PCA components on S2. Forward selection is greedy and unstable.</a:t>
-            </a:r>
-          </a:p>
-        </p:txBody>
-      </p:sp>
-      <p:sp>
-        <p:nvSpPr>
-          <p:cNvPr id="10" name="Rounded Rectangle 9"/>
-          <p:cNvSpPr/>
-          <p:nvPr/>
-        </p:nvSpPr>
-        <p:spPr>
-          <a:xfrm>
-            <a:off x="6309360" y="4754880"/>
-            <a:ext cx="5349240" cy="1463040"/>
-          </a:xfrm>
-          <a:prstGeom prst="roundRect">
-            <a:avLst>
-              <a:gd name="adj" fmla="val 8000"/>
-            </a:avLst>
-          </a:prstGeom>
-          <a:solidFill>
-            <a:srgbClr val="F1F5FB"/>
-          </a:solidFill>
-          <a:ln>
-            <a:noFill/>
-          </a:ln>
-          <a:effectLst/>
-        </p:spPr>
-        <p:style>
-          <a:lnRef idx="1">
-            <a:schemeClr val="accent1"/>
-          </a:lnRef>
-          <a:fillRef idx="3">
-            <a:schemeClr val="accent1"/>
-          </a:fillRef>
-          <a:effectRef idx="2">
-            <a:schemeClr val="accent1"/>
-          </a:effectRef>
-          <a:fontRef idx="minor">
-            <a:schemeClr val="lt1"/>
-          </a:fontRef>
-        </p:style>
-        <p:txBody>
-          <a:bodyPr rtlCol="0" anchor="ctr"/>
-          <a:lstStyle/>
-          <a:p>
-            <a:pPr algn="ctr"/>
-          </a:p>
-        </p:txBody>
-      </p:sp>
-      <p:sp>
-        <p:nvSpPr>
-          <p:cNvPr id="11" name="TextBox 10"/>
-          <p:cNvSpPr txBox="1"/>
-          <p:nvPr/>
-        </p:nvSpPr>
-        <p:spPr>
-          <a:xfrm>
-            <a:off x="6537960" y="4873752"/>
-            <a:ext cx="4937760" cy="1280160"/>
-          </a:xfrm>
-          <a:prstGeom prst="rect">
-            <a:avLst/>
-          </a:prstGeom>
-          <a:noFill/>
-        </p:spPr>
-        <p:txBody>
-          <a:bodyPr wrap="square" anchor="t" lIns="0" rIns="0" tIns="0" bIns="0">
-            <a:spAutoFit/>
-          </a:bodyPr>
-          <a:lstStyle/>
-          <a:p>
-            <a:pPr algn="l">
-              <a:spcAft>
-                <a:spcPts val="400"/>
-              </a:spcAft>
-            </a:pPr>
-            <a:r>
-              <a:rPr sz="1700" b="1" i="0">
-                <a:solidFill>
-                  <a:srgbClr val="0F1B2D"/>
-                </a:solidFill>
-                <a:latin typeface="Calibri"/>
-              </a:rPr>
-              <a:t>People are different</a:t>
-            </a:r>
-          </a:p>
-          <a:p>
-            <a:pPr algn="l">
-              <a:spcAft>
-                <a:spcPts val="400"/>
-              </a:spcAft>
-            </a:pPr>
-            <a:r>
-              <a:rPr sz="1400" b="0" i="0">
-                <a:solidFill>
-                  <a:srgbClr val="555B66"/>
-                </a:solidFill>
-                <a:latin typeface="Calibri"/>
-              </a:rPr>
-              <a:t>S1 → S2: MSE 0.152 vs 0.036 for the mean. Per-subject z-scoring → 0.046. Personal models are needed.</a:t>
-            </a:r>
-          </a:p>
-        </p:txBody>
-      </p:sp>
-    </p:spTree>
-  </p:cSld>
-  <p:clrMapOvr>
-    <a:masterClrMapping/>
-  </p:clrMapOvr>
-</p:sld>
-</file>
-
-<file path=ppt/slides/slide15.xml><?xml version="1.0" encoding="utf-8"?>
-<p:sld xmlns:a="http://schemas.openxmlformats.org/drawingml/2006/main" xmlns:p="http://schemas.openxmlformats.org/presentationml/2006/main" xmlns:r="http://schemas.openxmlformats.org/officeDocument/2006/relationships">
-  <p:cSld>
-    <p:bg>
-      <p:bgPr>
-        <a:solidFill>
-          <a:srgbClr val="FFFFFF"/>
-        </a:solidFill>
-        <a:effectLst/>
-      </p:bgPr>
-    </p:bg>
-    <p:spTree>
-      <p:nvGrpSpPr>
-        <p:cNvPr id="1" name=""/>
-        <p:cNvGrpSpPr/>
-        <p:nvPr/>
-      </p:nvGrpSpPr>
-      <p:grpSpPr/>
-      <p:sp>
-        <p:nvSpPr>
-          <p:cNvPr id="2" name="TextBox 1"/>
-          <p:cNvSpPr txBox="1"/>
-          <p:nvPr/>
-        </p:nvSpPr>
-        <p:spPr>
-          <a:xfrm>
-            <a:off x="548640" y="347472"/>
-            <a:ext cx="9144000" cy="274320"/>
-          </a:xfrm>
-          <a:prstGeom prst="rect">
-            <a:avLst/>
-          </a:prstGeom>
-          <a:noFill/>
-        </p:spPr>
-        <p:txBody>
-          <a:bodyPr wrap="square" anchor="t" lIns="0" rIns="0" tIns="0" bIns="0">
-            <a:spAutoFit/>
-          </a:bodyPr>
-          <a:lstStyle/>
-          <a:p>
-            <a:pPr algn="l"/>
-            <a:r>
-              <a:rPr sz="1200" b="1" i="0">
-                <a:solidFill>
-                  <a:srgbClr val="2A78D6"/>
-                </a:solidFill>
-                <a:latin typeface="Calibri"/>
-              </a:rPr>
-              <a:t>BACKUP · RELIABILITY</a:t>
-            </a:r>
-          </a:p>
-        </p:txBody>
-      </p:sp>
-      <p:sp>
-        <p:nvSpPr>
-          <p:cNvPr id="3" name="TextBox 2"/>
-          <p:cNvSpPr txBox="1"/>
-          <p:nvPr/>
-        </p:nvSpPr>
-        <p:spPr>
-          <a:xfrm>
-            <a:off x="548640" y="621792"/>
-            <a:ext cx="11064240" cy="731520"/>
-          </a:xfrm>
-          <a:prstGeom prst="rect">
-            <a:avLst/>
-          </a:prstGeom>
-          <a:noFill/>
-        </p:spPr>
-        <p:txBody>
-          <a:bodyPr wrap="square" anchor="t" lIns="0" rIns="0" tIns="0" bIns="0">
-            <a:spAutoFit/>
-          </a:bodyPr>
-          <a:lstStyle/>
-          <a:p>
-            <a:pPr algn="l"/>
-            <a:r>
-              <a:rPr sz="3000" b="1" i="0">
-                <a:solidFill>
-                  <a:srgbClr val="0F1B2D"/>
-                </a:solidFill>
-                <a:latin typeface="Cambria"/>
-              </a:rPr>
-              <a:t>The model knows when it is unsure, and more data would help</a:t>
-            </a:r>
-          </a:p>
-        </p:txBody>
-      </p:sp>
-      <p:sp>
-        <p:nvSpPr>
-          <p:cNvPr id="4" name="TextBox 3"/>
-          <p:cNvSpPr txBox="1"/>
-          <p:nvPr/>
-        </p:nvSpPr>
-        <p:spPr>
-          <a:xfrm>
-            <a:off x="548640" y="6419088"/>
-            <a:ext cx="7315200" cy="274320"/>
-          </a:xfrm>
-          <a:prstGeom prst="rect">
-            <a:avLst/>
-          </a:prstGeom>
-          <a:noFill/>
-        </p:spPr>
-        <p:txBody>
-          <a:bodyPr wrap="square" anchor="t" lIns="0" rIns="0" tIns="0" bIns="0">
-            <a:spAutoFit/>
-          </a:bodyPr>
-          <a:lstStyle/>
-          <a:p>
-            <a:pPr algn="l"/>
-            <a:r>
-              <a:rPr sz="1000" b="0" i="0">
-                <a:solidFill>
-                  <a:srgbClr val="555B66"/>
-                </a:solidFill>
-                <a:latin typeface="Calibri"/>
-              </a:rPr>
-              <a:t>MetaCost · Predicting metabolic cost during HILO</a:t>
-            </a:r>
-          </a:p>
-        </p:txBody>
-      </p:sp>
-      <p:sp>
-        <p:nvSpPr>
-          <p:cNvPr id="5" name="TextBox 4"/>
-          <p:cNvSpPr txBox="1"/>
-          <p:nvPr/>
-        </p:nvSpPr>
-        <p:spPr>
-          <a:xfrm>
-            <a:off x="10972800" y="6419088"/>
-            <a:ext cx="667512" cy="274320"/>
-          </a:xfrm>
-          <a:prstGeom prst="rect">
-            <a:avLst/>
-          </a:prstGeom>
-          <a:noFill/>
-        </p:spPr>
-        <p:txBody>
-          <a:bodyPr wrap="square" anchor="t" lIns="0" rIns="0" tIns="0" bIns="0">
-            <a:spAutoFit/>
-          </a:bodyPr>
-          <a:lstStyle/>
-          <a:p>
-            <a:pPr algn="r"/>
-            <a:r>
-              <a:rPr sz="1000" b="0" i="0">
-                <a:solidFill>
-                  <a:srgbClr val="555B66"/>
-                </a:solidFill>
-                <a:latin typeface="Calibri"/>
-              </a:rPr>
-              <a:t>15</a:t>
-            </a:r>
-          </a:p>
-        </p:txBody>
-      </p:sp>
-      <p:pic>
-        <p:nvPicPr>
-          <p:cNvPr id="6" name="Picture 5" descr="F11_calibration.png"/>
-          <p:cNvPicPr>
-            <a:picLocks noChangeAspect="1"/>
-          </p:cNvPicPr>
-          <p:nvPr/>
-        </p:nvPicPr>
-        <p:blipFill>
-          <a:blip r:embed="rId3"/>
-          <a:stretch>
-            <a:fillRect/>
-          </a:stretch>
-        </p:blipFill>
-        <p:spPr>
-          <a:xfrm>
-            <a:off x="728197" y="1371600"/>
-            <a:ext cx="3664245" cy="3429000"/>
-          </a:xfrm>
-          <a:prstGeom prst="rect">
-            <a:avLst/>
-          </a:prstGeom>
-        </p:spPr>
-      </p:pic>
-      <p:pic>
-        <p:nvPicPr>
-          <p:cNvPr id="7" name="Picture 6" descr="F10_learning_curve.png"/>
-          <p:cNvPicPr>
-            <a:picLocks noChangeAspect="1"/>
-          </p:cNvPicPr>
-          <p:nvPr/>
-        </p:nvPicPr>
-        <p:blipFill>
-          <a:blip r:embed="rId4"/>
-          <a:stretch>
-            <a:fillRect/>
-          </a:stretch>
-        </p:blipFill>
-        <p:spPr>
-          <a:xfrm>
-            <a:off x="4754880" y="1696212"/>
-            <a:ext cx="6949440" cy="2779776"/>
-          </a:xfrm>
-          <a:prstGeom prst="rect">
-            <a:avLst/>
-          </a:prstGeom>
-        </p:spPr>
-      </p:pic>
-      <p:sp>
-        <p:nvSpPr>
-          <p:cNvPr id="8" name="Rounded Rectangle 7"/>
-          <p:cNvSpPr/>
-          <p:nvPr/>
-        </p:nvSpPr>
-        <p:spPr>
-          <a:xfrm>
-            <a:off x="548640" y="4983480"/>
-            <a:ext cx="4023360" cy="1417320"/>
-          </a:xfrm>
-          <a:prstGeom prst="roundRect">
-            <a:avLst>
-              <a:gd name="adj" fmla="val 8000"/>
-            </a:avLst>
-          </a:prstGeom>
-          <a:solidFill>
-            <a:srgbClr val="F1F5FB"/>
-          </a:solidFill>
-          <a:ln>
-            <a:noFill/>
-          </a:ln>
-          <a:effectLst/>
-        </p:spPr>
-        <p:style>
-          <a:lnRef idx="1">
-            <a:schemeClr val="accent1"/>
-          </a:lnRef>
-          <a:fillRef idx="3">
-            <a:schemeClr val="accent1"/>
-          </a:fillRef>
-          <a:effectRef idx="2">
-            <a:schemeClr val="accent1"/>
-          </a:effectRef>
-          <a:fontRef idx="minor">
-            <a:schemeClr val="lt1"/>
-          </a:fontRef>
-        </p:style>
-        <p:txBody>
-          <a:bodyPr rtlCol="0" anchor="ctr"/>
-          <a:lstStyle/>
-          <a:p>
-            <a:pPr algn="ctr"/>
-          </a:p>
-        </p:txBody>
-      </p:sp>
-      <p:sp>
-        <p:nvSpPr>
-          <p:cNvPr id="9" name="TextBox 8"/>
-          <p:cNvSpPr txBox="1"/>
-          <p:nvPr/>
-        </p:nvSpPr>
-        <p:spPr>
-          <a:xfrm>
-            <a:off x="777240" y="5148072"/>
-            <a:ext cx="3566160" cy="685800"/>
-          </a:xfrm>
-          <a:prstGeom prst="rect">
-            <a:avLst/>
-          </a:prstGeom>
-          <a:noFill/>
-        </p:spPr>
-        <p:txBody>
-          <a:bodyPr wrap="square" anchor="t" lIns="0" rIns="0" tIns="0" bIns="0">
-            <a:spAutoFit/>
-          </a:bodyPr>
-          <a:lstStyle/>
-          <a:p>
-            <a:pPr algn="l"/>
-            <a:r>
-              <a:rPr sz="3200" b="1" i="0">
-                <a:solidFill>
-                  <a:srgbClr val="1BAF7A"/>
-                </a:solidFill>
-                <a:latin typeface="Cambria"/>
-              </a:rPr>
-              <a:t>94 %</a:t>
-            </a:r>
-          </a:p>
-        </p:txBody>
-      </p:sp>
-      <p:sp>
-        <p:nvSpPr>
-          <p:cNvPr id="10" name="TextBox 9"/>
-          <p:cNvSpPr txBox="1"/>
-          <p:nvPr/>
-        </p:nvSpPr>
-        <p:spPr>
-          <a:xfrm>
-            <a:off x="777240" y="5852160"/>
-            <a:ext cx="3566160" cy="502920"/>
-          </a:xfrm>
-          <a:prstGeom prst="rect">
-            <a:avLst/>
-          </a:prstGeom>
-          <a:noFill/>
-        </p:spPr>
-        <p:txBody>
-          <a:bodyPr wrap="square" anchor="t" lIns="0" rIns="0" tIns="0" bIns="0">
-            <a:spAutoFit/>
-          </a:bodyPr>
-          <a:lstStyle/>
-          <a:p>
-            <a:pPr algn="l"/>
-            <a:r>
-              <a:rPr sz="1300" b="0" i="0">
-                <a:solidFill>
-                  <a:srgbClr val="555B66"/>
-                </a:solidFill>
-                <a:latin typeface="Calibri"/>
-              </a:rPr>
-              <a:t>of unseen-day points inside the S1 95 % interval</a:t>
-            </a:r>
-          </a:p>
-        </p:txBody>
-      </p:sp>
-      <p:sp>
-        <p:nvSpPr>
-          <p:cNvPr id="11" name="Rounded Rectangle 10"/>
-          <p:cNvSpPr/>
-          <p:nvPr/>
-        </p:nvSpPr>
-        <p:spPr>
-          <a:xfrm>
-            <a:off x="4754880" y="4983480"/>
-            <a:ext cx="6903720" cy="1417320"/>
-          </a:xfrm>
-          <a:prstGeom prst="roundRect">
-            <a:avLst>
-              <a:gd name="adj" fmla="val 8000"/>
-            </a:avLst>
-          </a:prstGeom>
-          <a:solidFill>
-            <a:srgbClr val="F1F5FB"/>
-          </a:solidFill>
-          <a:ln>
-            <a:noFill/>
-          </a:ln>
-          <a:effectLst/>
-        </p:spPr>
-        <p:style>
-          <a:lnRef idx="1">
-            <a:schemeClr val="accent1"/>
-          </a:lnRef>
-          <a:fillRef idx="3">
-            <a:schemeClr val="accent1"/>
-          </a:fillRef>
-          <a:effectRef idx="2">
-            <a:schemeClr val="accent1"/>
-          </a:effectRef>
-          <a:fontRef idx="minor">
-            <a:schemeClr val="lt1"/>
-          </a:fontRef>
-        </p:style>
-        <p:txBody>
-          <a:bodyPr rtlCol="0" anchor="ctr"/>
-          <a:lstStyle/>
-          <a:p>
-            <a:pPr algn="ctr"/>
-          </a:p>
-        </p:txBody>
-      </p:sp>
-      <p:sp>
-        <p:nvSpPr>
-          <p:cNvPr id="12" name="TextBox 11"/>
-          <p:cNvSpPr txBox="1"/>
-          <p:nvPr/>
-        </p:nvSpPr>
-        <p:spPr>
-          <a:xfrm>
-            <a:off x="4983480" y="5148072"/>
-            <a:ext cx="6446520" cy="685800"/>
-          </a:xfrm>
-          <a:prstGeom prst="rect">
-            <a:avLst/>
-          </a:prstGeom>
-          <a:noFill/>
-        </p:spPr>
-        <p:txBody>
-          <a:bodyPr wrap="square" anchor="t" lIns="0" rIns="0" tIns="0" bIns="0">
-            <a:spAutoFit/>
-          </a:bodyPr>
-          <a:lstStyle/>
-          <a:p>
-            <a:pPr algn="l"/>
-            <a:r>
-              <a:rPr sz="3200" b="1" i="0">
-                <a:solidFill>
-                  <a:srgbClr val="1BAF7A"/>
-                </a:solidFill>
-                <a:latin typeface="Cambria"/>
-              </a:rPr>
-              <a:t>0.0155 → 0.0088</a:t>
-            </a:r>
-          </a:p>
-        </p:txBody>
-      </p:sp>
-      <p:sp>
-        <p:nvSpPr>
-          <p:cNvPr id="13" name="TextBox 12"/>
-          <p:cNvSpPr txBox="1"/>
-          <p:nvPr/>
-        </p:nvSpPr>
-        <p:spPr>
-          <a:xfrm>
-            <a:off x="4983480" y="5852160"/>
-            <a:ext cx="6446520" cy="502920"/>
-          </a:xfrm>
-          <a:prstGeom prst="rect">
-            <a:avLst/>
-          </a:prstGeom>
-          <a:noFill/>
-        </p:spPr>
-        <p:txBody>
-          <a:bodyPr wrap="square" anchor="t" lIns="0" rIns="0" tIns="0" bIns="0">
-            <a:spAutoFit/>
-          </a:bodyPr>
-          <a:lstStyle/>
-          <a:p>
-            <a:pPr algn="l"/>
-            <a:r>
-              <a:rPr sz="1300" b="0" i="0">
-                <a:solidFill>
-                  <a:srgbClr val="555B66"/>
-                </a:solidFill>
-                <a:latin typeface="Calibri"/>
-              </a:rPr>
-              <a:t>S1 GP test MSE from 28 to 144 training samples, still decreasing</a:t>
             </a:r>
           </a:p>
         </p:txBody>

</xml_diff>